<commit_message>
Add name, roll number, class and college to the title slide of all three review decks
</commit_message>
<xml_diff>
--- a/review-1/Review-1-Presentation.pptx
+++ b/review-1/Review-1-Presentation.pptx
@@ -1804,7 +1804,7 @@
                 <a:ea typeface="Calibri" pitchFamily="34" charset="-122"/>
                 <a:cs typeface="Calibri" pitchFamily="34" charset="-120"/>
               </a:rPr>
-              <a:t>[ Your Name ]</a:t>
+              <a:t>BANGLA DEEKSHAN RAJ</a:t>
             </a:r>
             <a:endParaRPr lang="en-US" sz="1300" dirty="0"/>
           </a:p>
@@ -1824,7 +1824,7 @@
                 <a:ea typeface="Calibri" pitchFamily="34" charset="-122"/>
                 <a:cs typeface="Calibri" pitchFamily="34" charset="-120"/>
               </a:rPr>
-              <a:t>[ Roll No. / USN ]  ·  [ Class / Section ]</a:t>
+              <a:t>Roll No: 25WU0102037  ·  Class: AIML RHINOS</a:t>
             </a:r>
             <a:endParaRPr lang="en-US" sz="1300" dirty="0"/>
           </a:p>
@@ -1844,7 +1844,7 @@
                 <a:ea typeface="Calibri" pitchFamily="34" charset="-122"/>
                 <a:cs typeface="Calibri" pitchFamily="34" charset="-120"/>
               </a:rPr>
-              <a:t>[ College Name ] — Week 7 Review</a:t>
+              <a:t>WOXSEN UNIVERSITY — Week 7 Review</a:t>
             </a:r>
             <a:endParaRPr lang="en-US" sz="1300" dirty="0"/>
           </a:p>

</xml_diff>